<commit_message>
aprimorando mais a apresentação
</commit_message>
<xml_diff>
--- a/docs/assets/apresentacao.pptx
+++ b/docs/assets/apresentacao.pptx
@@ -6444,6 +6444,48 @@
       </p:sp>
       <p:sp>
         <p:nvSpPr>
+          <p:cNvPr id="901" name="Text 901"/>
+          <p:cNvSpPr/>
+          <p:nvPr/>
+        </p:nvSpPr>
+        <p:spPr>
+          <a:xfrm>
+            <a:off x="5669280" y="2148840"/>
+            <a:ext cx="2621128" cy="502920"/>
+          </a:xfrm>
+          <a:prstGeom prst="rect">
+            <a:avLst/>
+          </a:prstGeom>
+          <a:noFill/>
+          <a:ln/>
+        </p:spPr>
+        <p:txBody>
+          <a:bodyPr wrap="square" lIns="0" tIns="0" rIns="0" bIns="0" rtlCol="0" anchor="t"/>
+          <a:lstStyle/>
+          <a:p>
+            <a:pPr algn="l" indent="0" marL="0">
+              <a:lnSpc>
+                <a:spcPct val="110000"/>
+              </a:lnSpc>
+              <a:buNone/>
+            </a:pPr>
+            <a:r>
+              <a:rPr lang="en-US" sz="1200" dirty="0">
+                <a:solidFill>
+                  <a:srgbClr val="5B6068"/>
+                </a:solidFill>
+                <a:latin typeface="Calibri" pitchFamily="34" charset="0"/>
+                <a:ea typeface="Calibri" pitchFamily="34" charset="-122"/>
+                <a:cs typeface="Calibri" pitchFamily="34" charset="-120"/>
+              </a:rPr>
+              <a:t>AWS IAM, MFA, Grupos IAM</a:t>
+            </a:r>
+            <a:endParaRPr lang="en-US" sz="1200" dirty="0"/>
+          </a:p>
+        </p:txBody>
+      </p:sp>
+      <p:sp>
+        <p:nvSpPr>
           <p:cNvPr id="12" name="Shape 10"/>
           <p:cNvSpPr/>
           <p:nvPr/>
@@ -6551,6 +6593,48 @@
       </p:sp>
       <p:sp>
         <p:nvSpPr>
+          <p:cNvPr id="902" name="Text 902"/>
+          <p:cNvSpPr/>
+          <p:nvPr/>
+        </p:nvSpPr>
+        <p:spPr>
+          <a:xfrm>
+            <a:off x="8747608" y="2148840"/>
+            <a:ext cx="2621128" cy="502920"/>
+          </a:xfrm>
+          <a:prstGeom prst="rect">
+            <a:avLst/>
+          </a:prstGeom>
+          <a:noFill/>
+          <a:ln/>
+        </p:spPr>
+        <p:txBody>
+          <a:bodyPr wrap="square" lIns="0" tIns="0" rIns="0" bIns="0" rtlCol="0" anchor="t"/>
+          <a:lstStyle/>
+          <a:p>
+            <a:pPr algn="l" indent="0" marL="0">
+              <a:lnSpc>
+                <a:spcPct val="110000"/>
+              </a:lnSpc>
+              <a:buNone/>
+            </a:pPr>
+            <a:r>
+              <a:rPr lang="en-US" sz="1200" dirty="0">
+                <a:solidFill>
+                  <a:srgbClr val="5B6068"/>
+                </a:solidFill>
+                <a:latin typeface="Calibri" pitchFamily="34" charset="0"/>
+                <a:ea typeface="Calibri" pitchFamily="34" charset="-122"/>
+                <a:cs typeface="Calibri" pitchFamily="34" charset="-120"/>
+              </a:rPr>
+              <a:t>Security Groups (VPC)</a:t>
+            </a:r>
+            <a:endParaRPr lang="en-US" sz="1200" dirty="0"/>
+          </a:p>
+        </p:txBody>
+      </p:sp>
+      <p:sp>
+        <p:nvSpPr>
           <p:cNvPr id="15" name="Shape 13"/>
           <p:cNvSpPr/>
           <p:nvPr/>
@@ -6658,6 +6742,48 @@
       </p:sp>
       <p:sp>
         <p:nvSpPr>
+          <p:cNvPr id="903" name="Text 903"/>
+          <p:cNvSpPr/>
+          <p:nvPr/>
+        </p:nvSpPr>
+        <p:spPr>
+          <a:xfrm>
+            <a:off x="5669280" y="3721608"/>
+            <a:ext cx="2621128" cy="502920"/>
+          </a:xfrm>
+          <a:prstGeom prst="rect">
+            <a:avLst/>
+          </a:prstGeom>
+          <a:noFill/>
+          <a:ln/>
+        </p:spPr>
+        <p:txBody>
+          <a:bodyPr wrap="square" lIns="0" tIns="0" rIns="0" bIns="0" rtlCol="0" anchor="t"/>
+          <a:lstStyle/>
+          <a:p>
+            <a:pPr algn="l" indent="0" marL="0">
+              <a:lnSpc>
+                <a:spcPct val="110000"/>
+              </a:lnSpc>
+              <a:buNone/>
+            </a:pPr>
+            <a:r>
+              <a:rPr lang="en-US" sz="1200" dirty="0">
+                <a:solidFill>
+                  <a:srgbClr val="5B6068"/>
+                </a:solidFill>
+                <a:latin typeface="Calibri" pitchFamily="34" charset="0"/>
+                <a:ea typeface="Calibri" pitchFamily="34" charset="-122"/>
+                <a:cs typeface="Calibri" pitchFamily="34" charset="-120"/>
+              </a:rPr>
+              <a:t>AWS KMS, ACM, RDS/S3 Encryption</a:t>
+            </a:r>
+            <a:endParaRPr lang="en-US" sz="1200" dirty="0"/>
+          </a:p>
+        </p:txBody>
+      </p:sp>
+      <p:sp>
+        <p:nvSpPr>
           <p:cNvPr id="18" name="Shape 16"/>
           <p:cNvSpPr/>
           <p:nvPr/>
@@ -6799,7 +6925,7 @@
                 <a:ea typeface="Calibri" pitchFamily="34" charset="-122"/>
                 <a:cs typeface="Calibri" pitchFamily="34" charset="-120"/>
               </a:rPr>
-              <a:t>Desmembrado de um pacote único.</a:t>
+              <a:t>AWS Secrets Manager</a:t>
             </a:r>
             <a:endParaRPr lang="en-US" sz="1200" dirty="0"/>
           </a:p>
@@ -6948,7 +7074,7 @@
                 <a:ea typeface="Calibri" pitchFamily="34" charset="-122"/>
                 <a:cs typeface="Calibri" pitchFamily="34" charset="-120"/>
               </a:rPr>
-              <a:t>Desmembrado de um pacote único.</a:t>
+              <a:t>AWS CloudTrail</a:t>
             </a:r>
             <a:endParaRPr lang="en-US" sz="1200" dirty="0"/>
           </a:p>
@@ -7097,7 +7223,7 @@
                 <a:ea typeface="Calibri" pitchFamily="34" charset="-122"/>
                 <a:cs typeface="Calibri" pitchFamily="34" charset="-120"/>
               </a:rPr>
-              <a:t>Antes evolução futura, agora pacote ativo com CloudWatch.</a:t>
+              <a:t>Amazon CloudWatch (Logs, Alarms, Dashboards)</a:t>
             </a:r>
             <a:endParaRPr lang="en-US" sz="1200" dirty="0"/>
           </a:p>

</xml_diff>